<commit_message>
Add terminal version (cli.py) with approval prompt
Runs the same agent, tools and human approval without the dashboard.
Prints the agent steps, sources and PDF excerpts, and asks
"Approve writing the report? [y/N]". Adds a sample PDF, 3 CLI tests
(126 total), and README/slides updates.

Co-Authored-By: Claude Opus 5.5 (1M context) <noreply@anthropic.com>
</commit_message>
<xml_diff>
--- a/slides/Mini-Muse-Step-by-Step-Implementation.pptx
+++ b/slides/Mini-Muse-Step-by-Step-Implementation.pptx
@@ -13905,7 +13905,7 @@
                 </a:solidFill>
                 <a:latin typeface="Consolas"/>
               </a:rPr>
-              <a:t>123 passed, 2 skipped in 0.8s                           </a:t>
+              <a:t>126 passed, 2 skipped in 2.7s                           </a:t>
             </a:r>
             <a:r>
               <a:rPr sz="1250">
@@ -16914,7 +16914,7 @@
                 </a:solidFill>
                 <a:latin typeface="Carlito"/>
               </a:rPr>
-              <a:t>Chat UI + 123 offline tests</a:t>
+              <a:t>Chat UI + 126 offline tests</a:t>
             </a:r>
           </a:p>
         </p:txBody>
@@ -19818,7 +19818,7 @@
                 </a:solidFill>
                 <a:latin typeface="Caladea"/>
               </a:rPr>
-              <a:t>123</a:t>
+              <a:t>126</a:t>
             </a:r>
           </a:p>
         </p:txBody>
@@ -21419,7 +21419,7 @@
                           </a:solidFill>
                           <a:latin typeface="Carlito"/>
                         </a:rPr>
-                        <a:t>123 offline tests + 2 live tests</a:t>
+                        <a:t>126 offline tests + 2 live tests</a:t>
                       </a:r>
                     </a:p>
                   </a:txBody>

</xml_diff>